<commit_message>
refacut sectiunea AI cu prompturi tintite
</commit_message>
<xml_diff>
--- a/TSS_Prezentare_T4.pptx
+++ b/TSS_Prezentare_T4.pptx
@@ -4609,7 +4609,7 @@
               </a:defRPr>
             </a:pPr>
             <a:r>
-              <a:t>  •  Testele AI sunt utile ca punct de plecare, dar necesita rafinare manuala</a:t>
+              <a:t>  •  Prompturile tintite multi-platforma (ChatGPT/Gemini/Claude) demonstreaza metodologia, dar halucineaza API-ul</a:t>
             </a:r>
           </a:p>
           <a:p>
@@ -4805,6 +4805,30 @@
           </a:p>
         </p:txBody>
       </p:sp>
+      <p:pic>
+        <p:nvPicPr>
+          <p:cNvPr id="25" name="Picture 24" descr="commits.png"/>
+          <p:cNvPicPr>
+            <a:picLocks noChangeAspect="1"/>
+          </p:cNvPicPr>
+          <p:nvPr/>
+        </p:nvPicPr>
+        <p:blipFill>
+          <a:blip r:embed="rId2"/>
+          <a:stretch>
+            <a:fillRect/>
+          </a:stretch>
+        </p:blipFill>
+        <p:spPr>
+          <a:xfrm>
+            <a:off x="9006840" y="2834640"/>
+            <a:ext cx="2032000" cy="3657600"/>
+          </a:xfrm>
+          <a:prstGeom prst="rect">
+            <a:avLst/>
+          </a:prstGeom>
+        </p:spPr>
+      </p:pic>
     </p:spTree>
   </p:cSld>
   <p:clrMapOvr>
@@ -9479,7 +9503,7 @@
               </a:defRPr>
             </a:pPr>
             <a:r>
-              <a:t>  Metrica                             Teste Proprii     Teste AI (ChatGPT)</a:t>
+              <a:t>  Metrica                          Proprii    AI generic    AI tintit (5 prompturi, 3 platforme)</a:t>
             </a:r>
           </a:p>
           <a:p>
@@ -9495,7 +9519,7 @@
               </a:defRPr>
             </a:pPr>
             <a:r>
-              <a:t>  ───────────────────────────────────────────────────────────────────────────</a:t>
+              <a:t>  ─────────────────────────────────────────────────────────────────────────────────────────────────</a:t>
             </a:r>
           </a:p>
           <a:p>
@@ -9511,7 +9535,7 @@
               </a:defRPr>
             </a:pPr>
             <a:r>
-              <a:t>  Total teste                                   309                    ~85</a:t>
+              <a:t>  Total teste                          309           113                       49</a:t>
             </a:r>
           </a:p>
           <a:p>
@@ -9527,7 +9551,7 @@
               </a:defRPr>
             </a:pPr>
             <a:r>
-              <a:t>  Fisiere de test                                 5                      2</a:t>
+              <a:t>  Teste care trec                      309/309       113/113                   33/49 (67%)</a:t>
             </a:r>
           </a:p>
           <a:p>
@@ -9543,7 +9567,7 @@
               </a:defRPr>
             </a:pPr>
             <a:r>
-              <a:t>  Strategii acoperite              5 (EP,BVA,CC,PC,MT)           1 (generala)</a:t>
+              <a:t>  Strategii acoperite       5 (EP,BVA,CC,PC,MT)        1 (generala)         5 (EP,BVA,SC/BC,MC/DC,MT)</a:t>
             </a:r>
           </a:p>
           <a:p>
@@ -9559,7 +9583,7 @@
               </a:defRPr>
             </a:pPr>
             <a:r>
-              <a:t>  Statement coverage                           100%                    94%</a:t>
+              <a:t>  Platforme AI                          —           ChatGPT             ChatGPT + Gemini + Claude</a:t>
             </a:r>
           </a:p>
           <a:p>
@@ -9575,7 +9599,7 @@
               </a:defRPr>
             </a:pPr>
             <a:r>
-              <a:t>  Branch coverage                            98.91%                    78%</a:t>
+              <a:t>  Statement coverage                  100%             94%                     (overlap suite)</a:t>
             </a:r>
           </a:p>
           <a:p>
@@ -9591,7 +9615,7 @@
               </a:defRPr>
             </a:pPr>
             <a:r>
-              <a:t>  Function coverage                            100%                   100%</a:t>
+              <a:t>  Branch coverage                   98.91%             78%                     (overlap suite)</a:t>
             </a:r>
           </a:p>
           <a:p>
@@ -9607,7 +9631,7 @@
               </a:defRPr>
             </a:pPr>
             <a:r>
-              <a:t>  Mutation score                             90.32%                   ~72%</a:t>
+              <a:t>  Mutation score                    90.32%             ~72%                     +tinta pe mutanti</a:t>
             </a:r>
           </a:p>
           <a:p>
@@ -9623,7 +9647,7 @@
               </a:defRPr>
             </a:pPr>
             <a:r>
-              <a:t>  Organizare pe strategii                        DA                     NU</a:t>
+              <a:t>  Mapare test → metodologie            DA               NU                            DA (per describe)</a:t>
             </a:r>
           </a:p>
           <a:p>
@@ -9639,7 +9663,7 @@
               </a:defRPr>
             </a:pPr>
             <a:r>
-              <a:t>  Teste mutation-killing                         DA                     NU</a:t>
+              <a:t>  Halucinatii API                     n/a             putine                          multe (semantica)</a:t>
             </a:r>
           </a:p>
         </p:txBody>
@@ -9867,7 +9891,7 @@
               </a:defRPr>
             </a:pPr>
             <a:r>
-              <a:t>Avantaje teste AI</a:t>
+              <a:t>Prompt generic vs prompturi tintite multi-platforma</a:t>
             </a:r>
           </a:p>
           <a:p>
@@ -9883,7 +9907,7 @@
               </a:defRPr>
             </a:pPr>
             <a:r>
-              <a:t>  ✓  Viteza de generare (~85 teste in cateva secunde)</a:t>
+              <a:t>  ✓  Generic: 113 teste, 100% trec (ChatGPT, vede sursa)</a:t>
             </a:r>
           </a:p>
           <a:p>
@@ -9899,7 +9923,7 @@
               </a:defRPr>
             </a:pPr>
             <a:r>
-              <a:t>  ✓  Acoperire initiala buna fara efort</a:t>
+              <a:t>  ✓  Tintit: 49 teste cu intentie metodologica explicita, 3 platforme</a:t>
             </a:r>
           </a:p>
           <a:p>
@@ -9915,7 +9939,7 @@
               </a:defRPr>
             </a:pPr>
             <a:r>
-              <a:t>  ✓  Descoperire rapida a cazurilor de baza</a:t>
+              <a:t>  ✓  EP (ChatGPT): 17/17 = 100% — specificatia exhaustiva functioneaza</a:t>
             </a:r>
           </a:p>
           <a:p>
@@ -9931,7 +9955,7 @@
               </a:defRPr>
             </a:pPr>
             <a:r>
-              <a:t>  ✓  Util ca punct de plecare pentru teste manuale</a:t>
+              <a:t>  ⚠  Tintit: 16 esecuri din halucinatii API (categorii inventate, apel static)</a:t>
             </a:r>
           </a:p>
         </p:txBody>

</xml_diff>

<commit_message>
iteratie 2 la prompturi: mai detaliate, totul trece
</commit_message>
<xml_diff>
--- a/TSS_Prezentare_T4.pptx
+++ b/TSS_Prezentare_T4.pptx
@@ -4609,7 +4609,7 @@
               </a:defRPr>
             </a:pPr>
             <a:r>
-              <a:t>  •  Prompturile tintite multi-platforma (ChatGPT/Gemini/Claude) demonstreaza metodologia, dar halucineaza API-ul</a:t>
+              <a:t>  •  Prompturile tintite detaliate (ChatGPT/Gemini/Claude) ating 100% rata de trecere — calitatea prompt-ului = calitatea testelor</a:t>
             </a:r>
           </a:p>
           <a:p>
@@ -9535,7 +9535,7 @@
               </a:defRPr>
             </a:pPr>
             <a:r>
-              <a:t>  Total teste                          309           113                       49</a:t>
+              <a:t>  Total teste                          309           113                       45</a:t>
             </a:r>
           </a:p>
           <a:p>
@@ -9551,7 +9551,7 @@
               </a:defRPr>
             </a:pPr>
             <a:r>
-              <a:t>  Teste care trec                      309/309       113/113                   33/49 (67%)</a:t>
+              <a:t>  Teste care trec                      309/309       113/113                   45/45 (100%)</a:t>
             </a:r>
           </a:p>
           <a:p>
@@ -9663,7 +9663,7 @@
               </a:defRPr>
             </a:pPr>
             <a:r>
-              <a:t>  Halucinatii API                     n/a             putine                          multe (semantica)</a:t>
+              <a:t>  Foloseste sursa direct               DA               DA                                NU (doar specificatia)</a:t>
             </a:r>
           </a:p>
         </p:txBody>
@@ -9923,7 +9923,7 @@
               </a:defRPr>
             </a:pPr>
             <a:r>
-              <a:t>  ✓  Tintit: 49 teste cu intentie metodologica explicita, 3 platforme</a:t>
+              <a:t>  ✓  Tintit: 45 teste cu intentie metodologica explicita, 3 platforme</a:t>
             </a:r>
           </a:p>
           <a:p>
@@ -9939,7 +9939,7 @@
               </a:defRPr>
             </a:pPr>
             <a:r>
-              <a:t>  ✓  EP (ChatGPT): 17/17 = 100% — specificatia exhaustiva functioneaza</a:t>
+              <a:t>  ✓  100% trec dupa iteratia 2 (prompturi mai detaliate)</a:t>
             </a:r>
           </a:p>
           <a:p>
@@ -9955,7 +9955,7 @@
               </a:defRPr>
             </a:pPr>
             <a:r>
-              <a:t>  ⚠  Tintit: 16 esecuri din halucinatii API (categorii inventate, apel static)</a:t>
+              <a:t>  ✓  Iter 1 → 67% (halucinatii API), Iter 2 → 100% (constante + semnaturi inline)</a:t>
             </a:r>
           </a:p>
         </p:txBody>

</xml_diff>